<commit_message>
Embed real setup screenshots into the install guide
Replace the placeholder frames on the Phase 1-3 slides with captured screenshots
from a demo tenant:
- Slide 7: Entra API permissions
- Slide 8: connector Security tab (cropped before Client ID/secret fields)
- Slide 9: Copilot Studio agent with instructions

Screenshots saved under docs/screenshots per SHOTLIST.md naming.

Co-authored-by: Copilot App <223556219+Copilot@users.noreply.github.com>
Copilot-Session: 87224105-c45f-45ed-94b7-a6b22e2d65bb
</commit_message>
<xml_diff>
--- a/docs/GwinnIQ-Install-Guide.pptx
+++ b/docs/GwinnIQ-Install-Guide.pptx
@@ -11579,13 +11579,13 @@
             </a:avLst>
           </a:prstGeom>
           <a:solidFill>
-            <a:srgbClr val="EEF3FB"/>
+            <a:srgbClr val="FFFFFF"/>
           </a:solidFill>
-          <a:ln w="15875">
+          <a:ln w="12700">
             <a:solidFill>
-              <a:srgbClr val="1E2761"/>
+              <a:srgbClr val="E1E7F0"/>
             </a:solidFill>
-            <a:prstDash val="dash"/>
+            <a:prstDash val="solid"/>
           </a:ln>
         </p:spPr>
       </p:sp>
@@ -11597,13 +11597,11 @@
         </p:nvSpPr>
         <p:spPr>
           <a:xfrm>
-            <a:off x="8679028" y="3552444"/>
-            <a:ext cx="640080" cy="457200"/>
-          </a:xfrm>
-          <a:prstGeom prst="roundRect">
-            <a:avLst>
-              <a:gd name="adj" fmla="val 10000"/>
-            </a:avLst>
+            <a:off x="6446520" y="2331720"/>
+            <a:ext cx="5105095" cy="457200"/>
+          </a:xfrm>
+          <a:prstGeom prst="rect">
+            <a:avLst/>
           </a:prstGeom>
           <a:solidFill>
             <a:srgbClr val="1E2761"/>
@@ -11613,146 +11611,106 @@
       </p:sp>
       <p:sp>
         <p:nvSpPr>
-          <p:cNvPr id="24" name="Shape 22"/>
-          <p:cNvSpPr/>
-          <p:nvPr/>
-        </p:nvSpPr>
-        <p:spPr>
-          <a:xfrm>
-            <a:off x="8871052" y="3680460"/>
-            <a:ext cx="256032" cy="201168"/>
-          </a:xfrm>
-          <a:prstGeom prst="ellipse">
-            <a:avLst/>
-          </a:prstGeom>
-          <a:solidFill>
-            <a:srgbClr val="EEF3FB"/>
-          </a:solidFill>
-          <a:ln/>
-        </p:spPr>
-      </p:sp>
-      <p:sp>
-        <p:nvSpPr>
-          <p:cNvPr id="25" name="Shape 23"/>
-          <p:cNvSpPr/>
-          <p:nvPr/>
-        </p:nvSpPr>
-        <p:spPr>
-          <a:xfrm>
-            <a:off x="8907628" y="3497580"/>
-            <a:ext cx="182880" cy="82296"/>
-          </a:xfrm>
-          <a:prstGeom prst="rect">
-            <a:avLst/>
-          </a:prstGeom>
-          <a:solidFill>
-            <a:srgbClr val="1E2761"/>
-          </a:solidFill>
-          <a:ln/>
-        </p:spPr>
-      </p:sp>
-      <p:sp>
-        <p:nvSpPr>
-          <p:cNvPr id="26" name="Text 24"/>
-          <p:cNvSpPr/>
-          <p:nvPr/>
-        </p:nvSpPr>
-        <p:spPr>
-          <a:xfrm>
-            <a:off x="6583680" y="4569714"/>
-            <a:ext cx="4830775" cy="1627632"/>
-          </a:xfrm>
-          <a:prstGeom prst="rect">
-            <a:avLst/>
-          </a:prstGeom>
-          <a:noFill/>
-          <a:ln/>
-        </p:spPr>
-        <p:txBody>
-          <a:bodyPr wrap="square" rtlCol="0" anchor="t"/>
-          <a:lstStyle/>
-          <a:p>
-            <a:pPr algn="ctr" indent="0" marL="0">
-              <a:lnSpc>
-                <a:spcPct val="100000"/>
-              </a:lnSpc>
-              <a:buNone/>
-            </a:pPr>
-            <a:r>
-              <a:rPr lang="en-US" sz="1200" b="1" dirty="0">
-                <a:solidFill>
-                  <a:srgbClr val="1E2761"/>
-                </a:solidFill>
-                <a:latin typeface="Calibri" pitchFamily="34" charset="0"/>
-                <a:ea typeface="Calibri" pitchFamily="34" charset="-122"/>
-                <a:cs typeface="Calibri" pitchFamily="34" charset="-120"/>
-              </a:rPr>
-              <a:t>SCREENSHOT 1
-</a:t>
-            </a:r>
-            <a:pPr algn="ctr" indent="0" marL="0">
-              <a:lnSpc>
-                <a:spcPct val="100000"/>
-              </a:lnSpc>
+          <p:cNvPr id="24" name="Text 22"/>
+          <p:cNvSpPr/>
+          <p:nvPr/>
+        </p:nvSpPr>
+        <p:spPr>
+          <a:xfrm>
+            <a:off x="6629400" y="2331720"/>
+            <a:ext cx="4739335" cy="457200"/>
+          </a:xfrm>
+          <a:prstGeom prst="rect">
+            <a:avLst/>
+          </a:prstGeom>
+          <a:noFill/>
+          <a:ln/>
+        </p:spPr>
+        <p:txBody>
+          <a:bodyPr wrap="square" rtlCol="0" anchor="ctr"/>
+          <a:lstStyle/>
+          <a:p>
+            <a:pPr indent="0" marL="0">
+              <a:buNone/>
+            </a:pPr>
+            <a:r>
+              <a:rPr lang="en-US" sz="1100" b="1" dirty="0">
+                <a:solidFill>
+                  <a:srgbClr val="E8B54D"/>
+                </a:solidFill>
+                <a:latin typeface="Calibri" pitchFamily="34" charset="0"/>
+                <a:ea typeface="Calibri" pitchFamily="34" charset="-122"/>
+                <a:cs typeface="Calibri" pitchFamily="34" charset="-120"/>
+              </a:rPr>
+              <a:t>SCREENSHOT 1   </a:t>
+            </a:r>
+            <a:pPr indent="0" marL="0">
               <a:buNone/>
             </a:pPr>
             <a:r>
               <a:rPr lang="en-US" sz="1050" dirty="0">
                 <a:solidFill>
-                  <a:srgbClr val="6B7280"/>
-                </a:solidFill>
-                <a:latin typeface="Calibri" pitchFamily="34" charset="0"/>
-                <a:ea typeface="Calibri" pitchFamily="34" charset="-122"/>
-                <a:cs typeface="Calibri" pitchFamily="34" charset="-120"/>
-              </a:rPr>
-              <a:t>Entra → API permissions, showing both delegated scopes with "Granted" admin consent</a:t>
-            </a:r>
-            <a:endParaRPr lang="en-US" sz="1200" dirty="0"/>
-          </a:p>
-        </p:txBody>
-      </p:sp>
-      <p:sp>
-        <p:nvSpPr>
-          <p:cNvPr id="27" name="Text 25"/>
-          <p:cNvSpPr/>
-          <p:nvPr/>
-        </p:nvSpPr>
-        <p:spPr>
-          <a:xfrm>
-            <a:off x="6537960" y="6108192"/>
-            <a:ext cx="4922215" cy="237744"/>
-          </a:xfrm>
-          <a:prstGeom prst="rect">
-            <a:avLst/>
-          </a:prstGeom>
-          <a:noFill/>
-          <a:ln/>
-        </p:spPr>
-        <p:txBody>
-          <a:bodyPr wrap="square" rtlCol="0" anchor="ctr"/>
-          <a:lstStyle/>
-          <a:p>
-            <a:pPr algn="ctr" indent="0" marL="0">
-              <a:buNone/>
-            </a:pPr>
-            <a:r>
-              <a:rPr lang="en-US" sz="850" i="1" dirty="0">
-                <a:solidFill>
-                  <a:srgbClr val="6B7280"/>
-                </a:solidFill>
-                <a:latin typeface="Calibri" pitchFamily="34" charset="0"/>
-                <a:ea typeface="Calibri" pitchFamily="34" charset="-122"/>
-                <a:cs typeface="Calibri" pitchFamily="34" charset="-120"/>
-              </a:rPr>
-              <a:t>see SHOTLIST.md</a:t>
-            </a:r>
-            <a:endParaRPr lang="en-US" sz="850" dirty="0"/>
-          </a:p>
-        </p:txBody>
-      </p:sp>
-      <p:sp>
-        <p:nvSpPr>
-          <p:cNvPr id="28" name="Text 26"/>
+                  <a:srgbClr val="FFFFFF"/>
+                </a:solidFill>
+                <a:latin typeface="Calibri" pitchFamily="34" charset="0"/>
+                <a:ea typeface="Calibri" pitchFamily="34" charset="-122"/>
+                <a:cs typeface="Calibri" pitchFamily="34" charset="-120"/>
+              </a:rPr>
+              <a:t>Entra → API permissions</a:t>
+            </a:r>
+            <a:endParaRPr lang="en-US" sz="1100" dirty="0"/>
+          </a:p>
+        </p:txBody>
+      </p:sp>
+      <p:pic>
+        <p:nvPicPr>
+          <p:cNvPr id="25" name="Image 0" descr="C:/Users/agoodson/git/secure-score/copilot-worktrees/GwinnIQ/agoodson-microsoft-congenial-doodle/docs/screenshots/01-entra-api-permissions.png">    </p:cNvPr>
+          <p:cNvPicPr>
+            <a:picLocks noChangeAspect="1"/>
+          </p:cNvPicPr>
+          <p:nvPr/>
+        </p:nvPicPr>
+        <p:blipFill>
+          <a:blip r:embed="rId1"/>
+          <a:stretch>
+            <a:fillRect/>
+          </a:stretch>
+        </p:blipFill>
+        <p:spPr>
+          <a:xfrm>
+            <a:off x="6611112" y="3427547"/>
+            <a:ext cx="4775911" cy="2334627"/>
+          </a:xfrm>
+          <a:prstGeom prst="rect">
+            <a:avLst/>
+          </a:prstGeom>
+        </p:spPr>
+      </p:pic>
+      <p:sp>
+        <p:nvSpPr>
+          <p:cNvPr id="26" name="Shape 23"/>
+          <p:cNvSpPr/>
+          <p:nvPr/>
+        </p:nvSpPr>
+        <p:spPr>
+          <a:xfrm>
+            <a:off x="6611112" y="3427547"/>
+            <a:ext cx="4775911" cy="2334627"/>
+          </a:xfrm>
+          <a:prstGeom prst="rect">
+            <a:avLst/>
+          </a:prstGeom>
+          <a:ln w="12700">
+            <a:solidFill>
+              <a:srgbClr val="AAB4C4"/>
+            </a:solidFill>
+            <a:prstDash val="solid"/>
+          </a:ln>
+        </p:spPr>
+      </p:sp>
+      <p:sp>
+        <p:nvSpPr>
+          <p:cNvPr id="27" name="Text 24"/>
           <p:cNvSpPr/>
           <p:nvPr/>
         </p:nvSpPr>
@@ -11791,7 +11749,7 @@
       </p:sp>
       <p:sp>
         <p:nvSpPr>
-          <p:cNvPr id="29" name="Text 27"/>
+          <p:cNvPr id="28" name="Text 25"/>
           <p:cNvSpPr/>
           <p:nvPr/>
         </p:nvSpPr>
@@ -12772,13 +12730,13 @@
             </a:avLst>
           </a:prstGeom>
           <a:solidFill>
-            <a:srgbClr val="EEF3FB"/>
+            <a:srgbClr val="FFFFFF"/>
           </a:solidFill>
-          <a:ln w="15875">
+          <a:ln w="12700">
             <a:solidFill>
-              <a:srgbClr val="1E2761"/>
+              <a:srgbClr val="E1E7F0"/>
             </a:solidFill>
-            <a:prstDash val="dash"/>
+            <a:prstDash val="solid"/>
           </a:ln>
         </p:spPr>
       </p:sp>
@@ -12790,13 +12748,11 @@
         </p:nvSpPr>
         <p:spPr>
           <a:xfrm>
-            <a:off x="8679028" y="3552444"/>
-            <a:ext cx="640080" cy="457200"/>
-          </a:xfrm>
-          <a:prstGeom prst="roundRect">
-            <a:avLst>
-              <a:gd name="adj" fmla="val 10000"/>
-            </a:avLst>
+            <a:off x="6446520" y="2331720"/>
+            <a:ext cx="5105095" cy="457200"/>
+          </a:xfrm>
+          <a:prstGeom prst="rect">
+            <a:avLst/>
           </a:prstGeom>
           <a:solidFill>
             <a:srgbClr val="1E2761"/>
@@ -12806,146 +12762,106 @@
       </p:sp>
       <p:sp>
         <p:nvSpPr>
-          <p:cNvPr id="29" name="Shape 27"/>
-          <p:cNvSpPr/>
-          <p:nvPr/>
-        </p:nvSpPr>
-        <p:spPr>
-          <a:xfrm>
-            <a:off x="8871052" y="3680460"/>
-            <a:ext cx="256032" cy="201168"/>
-          </a:xfrm>
-          <a:prstGeom prst="ellipse">
-            <a:avLst/>
-          </a:prstGeom>
-          <a:solidFill>
-            <a:srgbClr val="EEF3FB"/>
-          </a:solidFill>
-          <a:ln/>
-        </p:spPr>
-      </p:sp>
-      <p:sp>
-        <p:nvSpPr>
-          <p:cNvPr id="30" name="Shape 28"/>
-          <p:cNvSpPr/>
-          <p:nvPr/>
-        </p:nvSpPr>
-        <p:spPr>
-          <a:xfrm>
-            <a:off x="8907628" y="3497580"/>
-            <a:ext cx="182880" cy="82296"/>
-          </a:xfrm>
-          <a:prstGeom prst="rect">
-            <a:avLst/>
-          </a:prstGeom>
-          <a:solidFill>
-            <a:srgbClr val="1E2761"/>
-          </a:solidFill>
-          <a:ln/>
-        </p:spPr>
-      </p:sp>
-      <p:sp>
-        <p:nvSpPr>
-          <p:cNvPr id="31" name="Text 29"/>
-          <p:cNvSpPr/>
-          <p:nvPr/>
-        </p:nvSpPr>
-        <p:spPr>
-          <a:xfrm>
-            <a:off x="6583680" y="4569714"/>
-            <a:ext cx="4830775" cy="1627632"/>
-          </a:xfrm>
-          <a:prstGeom prst="rect">
-            <a:avLst/>
-          </a:prstGeom>
-          <a:noFill/>
-          <a:ln/>
-        </p:spPr>
-        <p:txBody>
-          <a:bodyPr wrap="square" rtlCol="0" anchor="t"/>
-          <a:lstStyle/>
-          <a:p>
-            <a:pPr algn="ctr" indent="0" marL="0">
-              <a:lnSpc>
-                <a:spcPct val="100000"/>
-              </a:lnSpc>
-              <a:buNone/>
-            </a:pPr>
-            <a:r>
-              <a:rPr lang="en-US" sz="1200" b="1" dirty="0">
-                <a:solidFill>
-                  <a:srgbClr val="1E2761"/>
-                </a:solidFill>
-                <a:latin typeface="Calibri" pitchFamily="34" charset="0"/>
-                <a:ea typeface="Calibri" pitchFamily="34" charset="-122"/>
-                <a:cs typeface="Calibri" pitchFamily="34" charset="-120"/>
-              </a:rPr>
-              <a:t>SCREENSHOT 2
-</a:t>
-            </a:r>
-            <a:pPr algn="ctr" indent="0" marL="0">
-              <a:lnSpc>
-                <a:spcPct val="100000"/>
-              </a:lnSpc>
+          <p:cNvPr id="29" name="Text 27"/>
+          <p:cNvSpPr/>
+          <p:nvPr/>
+        </p:nvSpPr>
+        <p:spPr>
+          <a:xfrm>
+            <a:off x="6629400" y="2331720"/>
+            <a:ext cx="4739335" cy="457200"/>
+          </a:xfrm>
+          <a:prstGeom prst="rect">
+            <a:avLst/>
+          </a:prstGeom>
+          <a:noFill/>
+          <a:ln/>
+        </p:spPr>
+        <p:txBody>
+          <a:bodyPr wrap="square" rtlCol="0" anchor="ctr"/>
+          <a:lstStyle/>
+          <a:p>
+            <a:pPr indent="0" marL="0">
+              <a:buNone/>
+            </a:pPr>
+            <a:r>
+              <a:rPr lang="en-US" sz="1100" b="1" dirty="0">
+                <a:solidFill>
+                  <a:srgbClr val="E8B54D"/>
+                </a:solidFill>
+                <a:latin typeface="Calibri" pitchFamily="34" charset="0"/>
+                <a:ea typeface="Calibri" pitchFamily="34" charset="-122"/>
+                <a:cs typeface="Calibri" pitchFamily="34" charset="-120"/>
+              </a:rPr>
+              <a:t>SCREENSHOT 2   </a:t>
+            </a:r>
+            <a:pPr indent="0" marL="0">
               <a:buNone/>
             </a:pPr>
             <a:r>
               <a:rPr lang="en-US" sz="1050" dirty="0">
                 <a:solidFill>
-                  <a:srgbClr val="6B7280"/>
-                </a:solidFill>
-                <a:latin typeface="Calibri" pitchFamily="34" charset="0"/>
-                <a:ea typeface="Calibri" pitchFamily="34" charset="-122"/>
-                <a:cs typeface="Calibri" pitchFamily="34" charset="-120"/>
-              </a:rPr>
-              <a:t>The connector Security tab filled in, with "Enable on-behalf-of login" turned on</a:t>
-            </a:r>
-            <a:endParaRPr lang="en-US" sz="1200" dirty="0"/>
-          </a:p>
-        </p:txBody>
-      </p:sp>
-      <p:sp>
-        <p:nvSpPr>
-          <p:cNvPr id="32" name="Text 30"/>
-          <p:cNvSpPr/>
-          <p:nvPr/>
-        </p:nvSpPr>
-        <p:spPr>
-          <a:xfrm>
-            <a:off x="6537960" y="6108192"/>
-            <a:ext cx="4922215" cy="237744"/>
-          </a:xfrm>
-          <a:prstGeom prst="rect">
-            <a:avLst/>
-          </a:prstGeom>
-          <a:noFill/>
-          <a:ln/>
-        </p:spPr>
-        <p:txBody>
-          <a:bodyPr wrap="square" rtlCol="0" anchor="ctr"/>
-          <a:lstStyle/>
-          <a:p>
-            <a:pPr algn="ctr" indent="0" marL="0">
-              <a:buNone/>
-            </a:pPr>
-            <a:r>
-              <a:rPr lang="en-US" sz="850" i="1" dirty="0">
-                <a:solidFill>
-                  <a:srgbClr val="6B7280"/>
-                </a:solidFill>
-                <a:latin typeface="Calibri" pitchFamily="34" charset="0"/>
-                <a:ea typeface="Calibri" pitchFamily="34" charset="-122"/>
-                <a:cs typeface="Calibri" pitchFamily="34" charset="-120"/>
-              </a:rPr>
-              <a:t>see SHOTLIST.md</a:t>
-            </a:r>
-            <a:endParaRPr lang="en-US" sz="850" dirty="0"/>
-          </a:p>
-        </p:txBody>
-      </p:sp>
-      <p:sp>
-        <p:nvSpPr>
-          <p:cNvPr id="33" name="Text 31"/>
+                  <a:srgbClr val="FFFFFF"/>
+                </a:solidFill>
+                <a:latin typeface="Calibri" pitchFamily="34" charset="0"/>
+                <a:ea typeface="Calibri" pitchFamily="34" charset="-122"/>
+                <a:cs typeface="Calibri" pitchFamily="34" charset="-120"/>
+              </a:rPr>
+              <a:t>Connector → Security tab</a:t>
+            </a:r>
+            <a:endParaRPr lang="en-US" sz="1100" dirty="0"/>
+          </a:p>
+        </p:txBody>
+      </p:sp>
+      <p:pic>
+        <p:nvPicPr>
+          <p:cNvPr id="30" name="Image 0" descr="C:/Users/agoodson/git/secure-score/copilot-worktrees/GwinnIQ/agoodson-microsoft-congenial-doodle/docs/screenshots/02-connector-security.png">    </p:cNvPr>
+          <p:cNvPicPr>
+            <a:picLocks noChangeAspect="1"/>
+          </p:cNvPicPr>
+          <p:nvPr/>
+        </p:nvPicPr>
+        <p:blipFill>
+          <a:blip r:embed="rId1"/>
+          <a:stretch>
+            <a:fillRect/>
+          </a:stretch>
+        </p:blipFill>
+        <p:spPr>
+          <a:xfrm>
+            <a:off x="6611112" y="3533925"/>
+            <a:ext cx="4775911" cy="2121869"/>
+          </a:xfrm>
+          <a:prstGeom prst="rect">
+            <a:avLst/>
+          </a:prstGeom>
+        </p:spPr>
+      </p:pic>
+      <p:sp>
+        <p:nvSpPr>
+          <p:cNvPr id="31" name="Shape 28"/>
+          <p:cNvSpPr/>
+          <p:nvPr/>
+        </p:nvSpPr>
+        <p:spPr>
+          <a:xfrm>
+            <a:off x="6611112" y="3533925"/>
+            <a:ext cx="4775911" cy="2121869"/>
+          </a:xfrm>
+          <a:prstGeom prst="rect">
+            <a:avLst/>
+          </a:prstGeom>
+          <a:ln w="12700">
+            <a:solidFill>
+              <a:srgbClr val="AAB4C4"/>
+            </a:solidFill>
+            <a:prstDash val="solid"/>
+          </a:ln>
+        </p:spPr>
+      </p:sp>
+      <p:sp>
+        <p:nvSpPr>
+          <p:cNvPr id="32" name="Text 29"/>
           <p:cNvSpPr/>
           <p:nvPr/>
         </p:nvSpPr>
@@ -12984,7 +12900,7 @@
       </p:sp>
       <p:sp>
         <p:nvSpPr>
-          <p:cNvPr id="34" name="Text 32"/>
+          <p:cNvPr id="33" name="Text 30"/>
           <p:cNvSpPr/>
           <p:nvPr/>
         </p:nvSpPr>
@@ -13921,13 +13837,13 @@
             </a:avLst>
           </a:prstGeom>
           <a:solidFill>
-            <a:srgbClr val="EEF3FB"/>
+            <a:srgbClr val="FFFFFF"/>
           </a:solidFill>
-          <a:ln w="15875">
+          <a:ln w="12700">
             <a:solidFill>
-              <a:srgbClr val="1E2761"/>
+              <a:srgbClr val="E1E7F0"/>
             </a:solidFill>
-            <a:prstDash val="dash"/>
+            <a:prstDash val="solid"/>
           </a:ln>
         </p:spPr>
       </p:sp>
@@ -13939,13 +13855,11 @@
         </p:nvSpPr>
         <p:spPr>
           <a:xfrm>
-            <a:off x="8679028" y="3104388"/>
-            <a:ext cx="640080" cy="457200"/>
-          </a:xfrm>
-          <a:prstGeom prst="roundRect">
-            <a:avLst>
-              <a:gd name="adj" fmla="val 10000"/>
-            </a:avLst>
+            <a:off x="6446520" y="1691640"/>
+            <a:ext cx="5105095" cy="457200"/>
+          </a:xfrm>
+          <a:prstGeom prst="rect">
+            <a:avLst/>
           </a:prstGeom>
           <a:solidFill>
             <a:srgbClr val="1E2761"/>
@@ -13955,146 +13869,106 @@
       </p:sp>
       <p:sp>
         <p:nvSpPr>
-          <p:cNvPr id="26" name="Shape 24"/>
-          <p:cNvSpPr/>
-          <p:nvPr/>
-        </p:nvSpPr>
-        <p:spPr>
-          <a:xfrm>
-            <a:off x="8871052" y="3232404"/>
-            <a:ext cx="256032" cy="201168"/>
-          </a:xfrm>
-          <a:prstGeom prst="ellipse">
-            <a:avLst/>
-          </a:prstGeom>
-          <a:solidFill>
-            <a:srgbClr val="EEF3FB"/>
-          </a:solidFill>
-          <a:ln/>
-        </p:spPr>
-      </p:sp>
-      <p:sp>
-        <p:nvSpPr>
-          <p:cNvPr id="27" name="Shape 25"/>
-          <p:cNvSpPr/>
-          <p:nvPr/>
-        </p:nvSpPr>
-        <p:spPr>
-          <a:xfrm>
-            <a:off x="8907628" y="3049524"/>
-            <a:ext cx="182880" cy="82296"/>
-          </a:xfrm>
-          <a:prstGeom prst="rect">
-            <a:avLst/>
-          </a:prstGeom>
-          <a:solidFill>
-            <a:srgbClr val="1E2761"/>
-          </a:solidFill>
-          <a:ln/>
-        </p:spPr>
-      </p:sp>
-      <p:sp>
-        <p:nvSpPr>
-          <p:cNvPr id="28" name="Text 26"/>
-          <p:cNvSpPr/>
-          <p:nvPr/>
-        </p:nvSpPr>
-        <p:spPr>
-          <a:xfrm>
-            <a:off x="6583680" y="4281678"/>
-            <a:ext cx="4830775" cy="1883664"/>
-          </a:xfrm>
-          <a:prstGeom prst="rect">
-            <a:avLst/>
-          </a:prstGeom>
-          <a:noFill/>
-          <a:ln/>
-        </p:spPr>
-        <p:txBody>
-          <a:bodyPr wrap="square" rtlCol="0" anchor="t"/>
-          <a:lstStyle/>
-          <a:p>
-            <a:pPr algn="ctr" indent="0" marL="0">
-              <a:lnSpc>
-                <a:spcPct val="100000"/>
-              </a:lnSpc>
-              <a:buNone/>
-            </a:pPr>
-            <a:r>
-              <a:rPr lang="en-US" sz="1200" b="1" dirty="0">
-                <a:solidFill>
-                  <a:srgbClr val="1E2761"/>
-                </a:solidFill>
-                <a:latin typeface="Calibri" pitchFamily="34" charset="0"/>
-                <a:ea typeface="Calibri" pitchFamily="34" charset="-122"/>
-                <a:cs typeface="Calibri" pitchFamily="34" charset="-120"/>
-              </a:rPr>
-              <a:t>SCREENSHOT 3
-</a:t>
-            </a:r>
-            <a:pPr algn="ctr" indent="0" marL="0">
-              <a:lnSpc>
-                <a:spcPct val="100000"/>
-              </a:lnSpc>
+          <p:cNvPr id="26" name="Text 24"/>
+          <p:cNvSpPr/>
+          <p:nvPr/>
+        </p:nvSpPr>
+        <p:spPr>
+          <a:xfrm>
+            <a:off x="6629400" y="1691640"/>
+            <a:ext cx="4739335" cy="457200"/>
+          </a:xfrm>
+          <a:prstGeom prst="rect">
+            <a:avLst/>
+          </a:prstGeom>
+          <a:noFill/>
+          <a:ln/>
+        </p:spPr>
+        <p:txBody>
+          <a:bodyPr wrap="square" rtlCol="0" anchor="ctr"/>
+          <a:lstStyle/>
+          <a:p>
+            <a:pPr indent="0" marL="0">
+              <a:buNone/>
+            </a:pPr>
+            <a:r>
+              <a:rPr lang="en-US" sz="1100" b="1" dirty="0">
+                <a:solidFill>
+                  <a:srgbClr val="E8B54D"/>
+                </a:solidFill>
+                <a:latin typeface="Calibri" pitchFamily="34" charset="0"/>
+                <a:ea typeface="Calibri" pitchFamily="34" charset="-122"/>
+                <a:cs typeface="Calibri" pitchFamily="34" charset="-120"/>
+              </a:rPr>
+              <a:t>SCREENSHOT 3   </a:t>
+            </a:r>
+            <a:pPr indent="0" marL="0">
               <a:buNone/>
             </a:pPr>
             <a:r>
               <a:rPr lang="en-US" sz="1050" dirty="0">
                 <a:solidFill>
-                  <a:srgbClr val="6B7280"/>
-                </a:solidFill>
-                <a:latin typeface="Calibri" pitchFamily="34" charset="0"/>
-                <a:ea typeface="Calibri" pitchFamily="34" charset="-122"/>
-                <a:cs typeface="Calibri" pitchFamily="34" charset="-120"/>
-              </a:rPr>
-              <a:t>Copilot Studio agent with instructions pasted and the connector actions attached</a:t>
-            </a:r>
-            <a:endParaRPr lang="en-US" sz="1200" dirty="0"/>
-          </a:p>
-        </p:txBody>
-      </p:sp>
-      <p:sp>
-        <p:nvSpPr>
-          <p:cNvPr id="29" name="Text 27"/>
-          <p:cNvSpPr/>
-          <p:nvPr/>
-        </p:nvSpPr>
-        <p:spPr>
-          <a:xfrm>
-            <a:off x="6537960" y="6108192"/>
-            <a:ext cx="4922215" cy="237744"/>
-          </a:xfrm>
-          <a:prstGeom prst="rect">
-            <a:avLst/>
-          </a:prstGeom>
-          <a:noFill/>
-          <a:ln/>
-        </p:spPr>
-        <p:txBody>
-          <a:bodyPr wrap="square" rtlCol="0" anchor="ctr"/>
-          <a:lstStyle/>
-          <a:p>
-            <a:pPr algn="ctr" indent="0" marL="0">
-              <a:buNone/>
-            </a:pPr>
-            <a:r>
-              <a:rPr lang="en-US" sz="850" i="1" dirty="0">
-                <a:solidFill>
-                  <a:srgbClr val="6B7280"/>
-                </a:solidFill>
-                <a:latin typeface="Calibri" pitchFamily="34" charset="0"/>
-                <a:ea typeface="Calibri" pitchFamily="34" charset="-122"/>
-                <a:cs typeface="Calibri" pitchFamily="34" charset="-120"/>
-              </a:rPr>
-              <a:t>see SHOTLIST.md</a:t>
-            </a:r>
-            <a:endParaRPr lang="en-US" sz="850" dirty="0"/>
-          </a:p>
-        </p:txBody>
-      </p:sp>
-      <p:sp>
-        <p:nvSpPr>
-          <p:cNvPr id="30" name="Text 28"/>
+                  <a:srgbClr val="FFFFFF"/>
+                </a:solidFill>
+                <a:latin typeface="Calibri" pitchFamily="34" charset="0"/>
+                <a:ea typeface="Calibri" pitchFamily="34" charset="-122"/>
+                <a:cs typeface="Calibri" pitchFamily="34" charset="-120"/>
+              </a:rPr>
+              <a:t>Copilot Studio → GwinnIQ agent</a:t>
+            </a:r>
+            <a:endParaRPr lang="en-US" sz="1100" dirty="0"/>
+          </a:p>
+        </p:txBody>
+      </p:sp>
+      <p:pic>
+        <p:nvPicPr>
+          <p:cNvPr id="27" name="Image 0" descr="C:/Users/agoodson/git/secure-score/copilot-worktrees/GwinnIQ/agoodson-microsoft-congenial-doodle/docs/screenshots/03-copilot-studio-agent.png">    </p:cNvPr>
+          <p:cNvPicPr>
+            <a:picLocks noChangeAspect="1"/>
+          </p:cNvPicPr>
+          <p:nvPr/>
+        </p:nvPicPr>
+        <p:blipFill>
+          <a:blip r:embed="rId1"/>
+          <a:stretch>
+            <a:fillRect/>
+          </a:stretch>
+        </p:blipFill>
+        <p:spPr>
+          <a:xfrm>
+            <a:off x="6611112" y="2807733"/>
+            <a:ext cx="4775911" cy="2934174"/>
+          </a:xfrm>
+          <a:prstGeom prst="rect">
+            <a:avLst/>
+          </a:prstGeom>
+        </p:spPr>
+      </p:pic>
+      <p:sp>
+        <p:nvSpPr>
+          <p:cNvPr id="28" name="Shape 25"/>
+          <p:cNvSpPr/>
+          <p:nvPr/>
+        </p:nvSpPr>
+        <p:spPr>
+          <a:xfrm>
+            <a:off x="6611112" y="2807733"/>
+            <a:ext cx="4775911" cy="2934174"/>
+          </a:xfrm>
+          <a:prstGeom prst="rect">
+            <a:avLst/>
+          </a:prstGeom>
+          <a:ln w="12700">
+            <a:solidFill>
+              <a:srgbClr val="AAB4C4"/>
+            </a:solidFill>
+            <a:prstDash val="solid"/>
+          </a:ln>
+        </p:spPr>
+      </p:sp>
+      <p:sp>
+        <p:nvSpPr>
+          <p:cNvPr id="29" name="Text 26"/>
           <p:cNvSpPr/>
           <p:nvPr/>
         </p:nvSpPr>
@@ -14133,7 +14007,7 @@
       </p:sp>
       <p:sp>
         <p:nvSpPr>
-          <p:cNvPr id="31" name="Text 29"/>
+          <p:cNvPr id="30" name="Text 27"/>
           <p:cNvSpPr/>
           <p:nvPr/>
         </p:nvSpPr>

</xml_diff>